<commit_message>
Sunum ve dokumanlara grafik gerekcesi ve gurbuzluk aciklamasi ekle
- Ogrenme dokumani: 'konuma gore gurbuzluk' aciklamasi (S11),
  'hangi grafik neden var' bolumu - 5 panel tek tek (S12), 2 yeni Q&A (S13)
- Sunum slayt 18 speaker notes: 'makalede 2 grafik, bizde 5' Q&A aciklamasi
- Sunum plani: senkron Q&A notu
- pptx ve onizleme PDF yeniden uretildi

Co-Authored-By: Claude Opus 4.8 <noreply@anthropic.com>
</commit_message>
<xml_diff>
--- a/V-BLAST_Sunum.pptx
+++ b/V-BLAST_Sunum.pptx
@@ -1155,6 +1155,12 @@
           <a:p>
             <a:r>
               <a:t>Makaledeki ortamı doğrulamak için her şeyi MATLAB'de sıfırdan, hiçbir hazır toolbox fonksiyonu kullanmadan kodladık: 16-QAM modülasyonu, kanal, gürültü, pseudoinverse, sıralı iptalli alıcı — hepsi elle. Parametreler makaleyle aynı: sekiz verici, on iki alıcı, 16-QAM, bağımsız Rayleigh kanal. Her SNR noktasında binlerce burst üretip Monte Carlo ile blok ve bit hata oranını ölçtük. Sırasıyla dört şey göstereceğim: ana karşılaştırma, sıralamanın etkisi, alıcı tipinin etkisi ve anten sayısının etkisi.</a:t>
+            </a:r>
+          </a:p>
+          <a:p/>
+          <a:p>
+            <a:r>
+              <a:t>[Olası soru — Makalede 2 grafik var, sizde 5, neden?] Makale tek bir gerçek donanım senaryosunu kanıtlamayı hedefledi: Şekil 2 temel kazancı, Şekil 3 ise konuma göre gürbüzlüğü gösterir. Biz aynı temel sonucu yeniden ürettik (SIM-1), sonra simülasyonun sağladığı esneklikle yöntemin her tasarım kararını ayrı ayrı doğruladık: sıralamanın etkisi (SIM-2), alıcı tipi ZF/MMSE (SIM-3a), anten sayısı N (SIM-3b). Yani fazladan grafikler öğretici parametre süpürmeleridir. Makalenin Şekil 3'ünü (konuma göre gürbüzlük: vericiyi farklı yerlere taşıyıp performansın bozulmadığını göstermek) tekrarlamadık, çünkü ideal i.i.d. Rayleigh modelinde her konum istatistiksel olarak aynıdır — zaten binlerce rastgele kanal üzerinde ortalama alıyoruz; gerçek konum farkı için donanım ölçümü gerekir.</a:t>
             </a:r>
           </a:p>
         </p:txBody>

</xml_diff>